<commit_message>
Walkthrough: add slide 2, how Daniel works with the tool end to end
Co-Authored-By: Claude Opus 5.5 <noreply@anthropic.com>

Claude-Session: https://claude.ai/code/session_01ByzH1frcmfw13KzpW7TUcX
</commit_message>
<xml_diff>
--- a/deliverables/Nodule_Research_Copilot_Daniel_Walkthrough.pptx
+++ b/deliverables/Nodule_Research_Copilot_Daniel_Walkthrough.pptx
@@ -12,6 +12,7 @@
     <p:sldId id="260" r:id="rId12"/>
     <p:sldId id="261" r:id="rId13"/>
     <p:sldId id="262" r:id="rId14"/>
+    <p:sldId id="263" r:id="rId15"/>
   </p:sldIdLst>
   <p:sldSz cx="12192000" cy="6858000" type="screen4x3"/>
   <p:notesSz cx="6858000" cy="9144000"/>
@@ -529,7 +530,7 @@
           </a:p>
           <a:p>
             <a:r>
-              <a:t>- "Naomi's goal is about half of that. Today that is a goal, and slide 6 shows exactly how far we have got." (E2)</a:t>
+              <a:t>- "Naomi's goal is about half of that. Today that is a goal, and slide 7 shows exactly how far we have got." (E2)</a:t>
             </a:r>
           </a:p>
           <a:p>
@@ -604,38 +605,53 @@
           <a:lstStyle/>
           <a:p>
             <a:r>
-              <a:t>· Let AI propose the findings (2 min)</a:t>
+              <a:t>· From the hospital scan to your sheet (1.5 min)</a:t>
             </a:r>
           </a:p>
           <a:p/>
           <a:p>
             <a:r>
-              <a:t>- A real screenshot, a real public scan (RIDER), real model output. TotalSegmentator 2.18.0 ran on the whole CT. It</a:t>
-            </a:r>
-          </a:p>
-          <a:p>
-            <a:r>
-              <a:t>  was not told where to look, and no expert data goes into it (E20).</a:t>
-            </a:r>
-          </a:p>
-          <a:p>
-            <a:r>
-              <a:t>- It runs on the lab laptop before you sit down, about 100 seconds per scan (E6, from file timestamps). Nothing leaves</a:t>
-            </a:r>
-          </a:p>
-          <a:p>
-            <a:r>
-              <a:t>  the computer.</a:t>
-            </a:r>
-          </a:p>
-          <a:p>
-            <a:r>
-              <a:t>- Point at the worklist: N1 65.5 × 49.3 mm, 79,677 mm³, RUL; plus two tiny candidates. "Every one starts as *To</a:t>
-            </a:r>
-          </a:p>
-          <a:p>
-            <a:r>
-              <a:t>  review*. Nothing is exported until you accept it."</a:t>
+              <a:t>- "Before the AI: this is your day with it." Walk left to right. You export the scan as for any research scan →</a:t>
+            </a:r>
+          </a:p>
+          <a:p>
+            <a:r>
+              <a:t>  one command runs the AI (overnight if you like) → open the folder in Chrome → review, fix, approve → the sheet</a:t>
+            </a:r>
+          </a:p>
+          <a:p>
+            <a:r>
+              <a:t>  fills itself.</a:t>
+            </a:r>
+          </a:p>
+          <a:p>
+            <a:r>
+              <a:t>- Only step 4 needs his judgement. Steps 2, 3 and 5 are machine time (measured: ~97 s AI per scan; ~12 s to open</a:t>
+            </a:r>
+          </a:p>
+          <a:p>
+            <a:r>
+              <a:t>  two scans with AI).</a:t>
+            </a:r>
+          </a:p>
+          <a:p>
+            <a:r>
+              <a:t>- Privacy and IT: nothing leaves the lab computer, and the browser blocks other sites (E22). There is no server and no</a:t>
+            </a:r>
+          </a:p>
+          <a:p>
+            <a:r>
+              <a:t>  PACS connection, so no IT project, which is where last year's vendor stalled.</a:t>
+            </a:r>
+          </a:p>
+          <a:p>
+            <a:r>
+              <a:t>- Be honest about the manual part: export and one command. Next: a watched folder; writing back to PACS only if</a:t>
+            </a:r>
+          </a:p>
+          <a:p>
+            <a:r>
+              <a:t>  the hospital wants it. Ask him: "How do you get research scans out of PACS today?"</a:t>
             </a:r>
           </a:p>
         </p:txBody>
@@ -705,43 +721,38 @@
           <a:lstStyle/>
           <a:p>
             <a:r>
-              <a:t>· Review. Correct. Approve. (2.5 min)</a:t>
+              <a:t>· Let AI propose the findings (2 min)</a:t>
             </a:r>
           </a:p>
           <a:p/>
           <a:p>
             <a:r>
-              <a:t>- Left: the AI outline in cyan, the expert outline as dotted magenta. Right: after brush strokes on 5 slices.</a:t>
-            </a:r>
-          </a:p>
-          <a:p>
-            <a:r>
-              <a:t>- Read the table: volume 43.8 → 46.8 mL, toward the expert's 55.0. One stroke overshot the long axis (65.1 vs 59.8).</a:t>
-            </a:r>
-          </a:p>
-          <a:p>
-            <a:r>
-              <a:t>  "I'm showing that on purpose: the numbers update after every stroke, so you see a mistake right away and undo</a:t>
-            </a:r>
-          </a:p>
-          <a:p>
-            <a:r>
-              <a:t>  it with one key." (E8)</a:t>
-            </a:r>
-          </a:p>
-          <a:p>
-            <a:r>
-              <a:t>- Say plainly: *these strokes were made by our test script, not by a person*, so this shows the mechanism and says</a:t>
-            </a:r>
-          </a:p>
-          <a:p>
-            <a:r>
-              <a:t>  nothing about correction time.</a:t>
-            </a:r>
-          </a:p>
-          <a:p>
-            <a:r>
-              <a:t>- Mention **S** + click for anything the AI missed. It is logged as "added by researcher".</a:t>
+              <a:t>- A real screenshot, a real public scan (RIDER), real model output. TotalSegmentator 2.18.0 ran on the whole CT. It</a:t>
+            </a:r>
+          </a:p>
+          <a:p>
+            <a:r>
+              <a:t>  was not told where to look, and no expert data goes into it (E20).</a:t>
+            </a:r>
+          </a:p>
+          <a:p>
+            <a:r>
+              <a:t>- It runs on the lab laptop before you sit down, about 100 seconds per scan (E6, from file timestamps). Nothing leaves</a:t>
+            </a:r>
+          </a:p>
+          <a:p>
+            <a:r>
+              <a:t>  the computer.</a:t>
+            </a:r>
+          </a:p>
+          <a:p>
+            <a:r>
+              <a:t>- Point at the worklist: N1 65.5 × 49.3 mm, 79,677 mm³, RUL; plus two tiny candidates. "Every one starts as *To</a:t>
+            </a:r>
+          </a:p>
+          <a:p>
+            <a:r>
+              <a:t>  review*. Nothing is exported until you accept it."</a:t>
             </a:r>
           </a:p>
         </p:txBody>
@@ -811,33 +822,43 @@
           <a:lstStyle/>
           <a:p>
             <a:r>
-              <a:t>· Understand what changed (2 min)</a:t>
+              <a:t>· Review. Correct. Approve. (2.5 min)</a:t>
             </a:r>
           </a:p>
           <a:p/>
           <a:p>
             <a:r>
-              <a:t>- Baseline 2006-09-05 vs follow-up 2006-09-20, same patient. The app paired N1 with its earlier self automatically</a:t>
-            </a:r>
-          </a:p>
-          <a:p>
-            <a:r>
-              <a:t>  (38 mm apart) and computed the change: −10.1 mm long axis, −45.1 % volume. The "?" stays until you confirm (E9).</a:t>
-            </a:r>
-          </a:p>
-          <a:p>
-            <a:r>
-              <a:t>- Then the caution: the two scans were reconstructed differently (STANDARD vs LUNG kernel), the baseline has no</a:t>
-            </a:r>
-          </a:p>
-          <a:p>
-            <a:r>
-              <a:t>  expert outline, and even two scans on the same day differ by a median 10–17 % in volume (E10). "The app does the</a:t>
-            </a:r>
-          </a:p>
-          <a:p>
-            <a:r>
-              <a:t>  re-find and the arithmetic. Whether the tumour really shrank is your call."</a:t>
+              <a:t>- Left: the AI outline in cyan, the expert outline as dotted magenta. Right: after brush strokes on 5 slices.</a:t>
+            </a:r>
+          </a:p>
+          <a:p>
+            <a:r>
+              <a:t>- Read the table: volume 43.8 → 46.8 mL, toward the expert's 55.0. One stroke overshot the long axis (65.1 vs 59.8).</a:t>
+            </a:r>
+          </a:p>
+          <a:p>
+            <a:r>
+              <a:t>  "I'm showing that on purpose: the numbers update after every stroke, so you see a mistake right away and undo</a:t>
+            </a:r>
+          </a:p>
+          <a:p>
+            <a:r>
+              <a:t>  it with one key." (E8)</a:t>
+            </a:r>
+          </a:p>
+          <a:p>
+            <a:r>
+              <a:t>- Say plainly: *these strokes were made by our test script, not by a person*, so this shows the mechanism and says</a:t>
+            </a:r>
+          </a:p>
+          <a:p>
+            <a:r>
+              <a:t>  nothing about correction time.</a:t>
+            </a:r>
+          </a:p>
+          <a:p>
+            <a:r>
+              <a:t>- Mention **S** + click for anything the AI missed. It is logged as "added by researcher".</a:t>
             </a:r>
           </a:p>
         </p:txBody>
@@ -907,73 +928,33 @@
           <a:lstStyle/>
           <a:p>
             <a:r>
-              <a:t>· Small and ground-glass nodules (3 min)</a:t>
+              <a:t>· Understand what changed (2 min)</a:t>
             </a:r>
           </a:p>
           <a:p/>
           <a:p>
             <a:r>
-              <a:t>- "This is the slide you asked for." Start with the limitation: RIDER's smallest tumour is 12.9 mm, and there are no</a:t>
-            </a:r>
-          </a:p>
-          <a:p>
-            <a:r>
-              <a:t>  ground-glass labels.</a:t>
-            </a:r>
-          </a:p>
-          <a:p>
-            <a:r>
-              <a:t>- On tumours ≤ 30 mm: 15 of 18 found, but outlines are worse (Dice 0.68, volume 39 % off) (E12). On the 12 smallest,</a:t>
-            </a:r>
-          </a:p>
-          <a:p>
-            <a:r>
-              <a:t>  every AI outline was too small, by 26–97 % (E13).</a:t>
-            </a:r>
-          </a:p>
-          <a:p>
-            <a:r>
-              <a:t>- The failure: the same 13 mm tumour was outlined at 8 mm on one scan and **missed** on the repeat 15 minutes later</a:t>
-            </a:r>
-          </a:p>
-          <a:p>
-            <a:r>
-              <a:t>  (E14). The success: 12.9 mm found with Dice 0.81, but 15 other candidates to reject on that scan (E15).</a:t>
-            </a:r>
-          </a:p>
-          <a:p>
-            <a:r>
-              <a:t>- Then the new test you asked for (E16): LIDC-IDRI, 15 scans, 35 nodules each outlined by at least 3 radiologists,</a:t>
-            </a:r>
-          </a:p>
-          <a:p>
-            <a:r>
-              <a:t>  with the radiologists' own texture ratings. Solid: 26 of 27 found, 15 of 16 at ≤ 10 mm. **Ground-glass: 0 of 5.**</a:t>
-            </a:r>
-          </a:p>
-          <a:p>
-            <a:r>
-              <a:t>  Part-solid: 1 of 3. Show the 15.8 mm ground-glass nodule with nothing on it (E21).</a:t>
-            </a:r>
-          </a:p>
-          <a:p>
-            <a:r>
-              <a:t>- Say what it means: for hazy nodules the AI does not help today, so he keeps searching for them himself. For</a:t>
-            </a:r>
-          </a:p>
-          <a:p>
-            <a:r>
-              <a:t>  solid nodules it finds them, but every outline is too small, so he redraws before using a volume.</a:t>
-            </a:r>
-          </a:p>
-          <a:p>
-            <a:r>
-              <a:t>- If asked how we know the scoring is right: we caught a bug in our own scorer (outlines flipped on 5 scans) before</a:t>
-            </a:r>
-          </a:p>
-          <a:p>
-            <a:r>
-              <a:t>  reporting. The fix is checked by the AI's candidates landing on the radiologists' nodules.</a:t>
+              <a:t>- Baseline 2006-09-05 vs follow-up 2006-09-20, same patient. The app paired N1 with its earlier self automatically</a:t>
+            </a:r>
+          </a:p>
+          <a:p>
+            <a:r>
+              <a:t>  (38 mm apart) and computed the change: −10.1 mm long axis, −45.1 % volume. The "?" stays until you confirm (E9).</a:t>
+            </a:r>
+          </a:p>
+          <a:p>
+            <a:r>
+              <a:t>- Then the caution: the two scans were reconstructed differently (STANDARD vs LUNG kernel), the baseline has no</a:t>
+            </a:r>
+          </a:p>
+          <a:p>
+            <a:r>
+              <a:t>  expert outline, and even two scans on the same day differ by a median 10–17 % in volume (E10). "The app does the</a:t>
+            </a:r>
+          </a:p>
+          <a:p>
+            <a:r>
+              <a:t>  re-find and the arithmetic. Whether the tumour really shrank is your call."</a:t>
             </a:r>
           </a:p>
         </p:txBody>
@@ -1043,33 +1024,73 @@
           <a:lstStyle/>
           <a:p>
             <a:r>
-              <a:t>· Does it actually save time? (2.5 min)</a:t>
+              <a:t>· Small and ground-glass nodules (3 min)</a:t>
             </a:r>
           </a:p>
           <a:p/>
           <a:p>
             <a:r>
-              <a:t>- Top row, measured: 53/59 found (stricter Dice ≥ 0.5: 43/59), Dice 0.76, a median of 3 extra candidates per scan,</a:t>
-            </a:r>
-          </a:p>
-          <a:p>
-            <a:r>
-              <a:t>  97 s of AI time per scan (E3–E6). Right card: the LIDC numbers repeat the slide 5 message (E16).</a:t>
-            </a:r>
-          </a:p>
-          <a:p>
-            <a:r>
-              <a:t>- The bar chart is the honest part: manual = your estimate; 50 % = the goal; with the tool = **not measured yet**</a:t>
-            </a:r>
-          </a:p>
-          <a:p>
-            <a:r>
-              <a:t>  (E17). The app already logs every action, correction, pause and export, so one timed session produces the answer.</a:t>
-            </a:r>
-          </a:p>
-          <a:p>
-            <a:r>
-              <a:t>- Machine time is seconds (E7). The open question is your review and correction time, especially on small nodules.</a:t>
+              <a:t>- "This is the slide you asked for." Start with the limitation: RIDER's smallest tumour is 12.9 mm, and there are no</a:t>
+            </a:r>
+          </a:p>
+          <a:p>
+            <a:r>
+              <a:t>  ground-glass labels.</a:t>
+            </a:r>
+          </a:p>
+          <a:p>
+            <a:r>
+              <a:t>- On tumours ≤ 30 mm: 15 of 18 found, but outlines are worse (Dice 0.68, volume 39 % off) (E12). On the 12 smallest,</a:t>
+            </a:r>
+          </a:p>
+          <a:p>
+            <a:r>
+              <a:t>  every AI outline was too small, by 26–97 % (E13).</a:t>
+            </a:r>
+          </a:p>
+          <a:p>
+            <a:r>
+              <a:t>- The failure: the same 13 mm tumour was outlined at 8 mm on one scan and **missed** on the repeat 15 minutes later</a:t>
+            </a:r>
+          </a:p>
+          <a:p>
+            <a:r>
+              <a:t>  (E14). The success: 12.9 mm found with Dice 0.81, but 15 other candidates to reject on that scan (E15).</a:t>
+            </a:r>
+          </a:p>
+          <a:p>
+            <a:r>
+              <a:t>- Then the new test you asked for (E16): LIDC-IDRI, 15 scans, 35 nodules each outlined by at least 3 radiologists,</a:t>
+            </a:r>
+          </a:p>
+          <a:p>
+            <a:r>
+              <a:t>  with the radiologists' own texture ratings. Solid: 26 of 27 found, 15 of 16 at ≤ 10 mm. **Ground-glass: 0 of 5.**</a:t>
+            </a:r>
+          </a:p>
+          <a:p>
+            <a:r>
+              <a:t>  Part-solid: 1 of 3. Show the 15.8 mm ground-glass nodule with nothing on it (E21).</a:t>
+            </a:r>
+          </a:p>
+          <a:p>
+            <a:r>
+              <a:t>- Say what it means: for hazy nodules the AI does not help today, so he keeps searching for them himself. For</a:t>
+            </a:r>
+          </a:p>
+          <a:p>
+            <a:r>
+              <a:t>  solid nodules it finds them, but every outline is too small, so he redraws before using a volume.</a:t>
+            </a:r>
+          </a:p>
+          <a:p>
+            <a:r>
+              <a:t>- If asked how we know the scoring is right: we caught a bug in our own scorer (outlines flipped on 5 scans) before</a:t>
+            </a:r>
+          </a:p>
+          <a:p>
+            <a:r>
+              <a:t>  reporting. The fix is checked by the AI's candidates landing on the radiologists' nodules.</a:t>
             </a:r>
           </a:p>
         </p:txBody>
@@ -1095,6 +1116,102 @@
 </file>
 
 <file path=ppt/notesSlides/notesSlide7.xml><?xml version="1.0" encoding="utf-8"?>
+<p:notes xmlns:a="http://schemas.openxmlformats.org/drawingml/2006/main" xmlns:p="http://schemas.openxmlformats.org/presentationml/2006/main" xmlns:r="http://schemas.openxmlformats.org/officeDocument/2006/relationships">
+  <p:cSld>
+    <p:spTree>
+      <p:nvGrpSpPr>
+        <p:cNvPr id="1" name=""/>
+        <p:cNvGrpSpPr/>
+        <p:nvPr/>
+      </p:nvGrpSpPr>
+      <p:grpSpPr>
+        <a:xfrm>
+          <a:off x="0" y="0"/>
+          <a:ext cx="0" cy="0"/>
+          <a:chOff x="0" y="0"/>
+          <a:chExt cx="0" cy="0"/>
+        </a:xfrm>
+      </p:grpSpPr>
+      <p:sp>
+        <p:nvSpPr>
+          <p:cNvPr id="2" name="Slide Image Placeholder 1"/>
+          <p:cNvSpPr>
+            <a:spLocks noGrp="1"/>
+          </p:cNvSpPr>
+          <p:nvPr>
+            <p:ph type="sldImg" idx="2"/>
+          </p:nvPr>
+        </p:nvSpPr>
+        <p:spPr/>
+      </p:sp>
+      <p:sp>
+        <p:nvSpPr>
+          <p:cNvPr id="3" name="Notes Placeholder 2"/>
+          <p:cNvSpPr>
+            <a:spLocks noGrp="1"/>
+          </p:cNvSpPr>
+          <p:nvPr>
+            <p:ph type="body" idx="3" sz="quarter"/>
+          </p:nvPr>
+        </p:nvSpPr>
+        <p:spPr/>
+        <p:txBody>
+          <a:bodyPr/>
+          <a:lstStyle/>
+          <a:p>
+            <a:r>
+              <a:t>· Does it actually save time? (2.5 min)</a:t>
+            </a:r>
+          </a:p>
+          <a:p/>
+          <a:p>
+            <a:r>
+              <a:t>- Top row, measured: 53/59 found (stricter Dice ≥ 0.5: 43/59), Dice 0.76, a median of 3 extra candidates per scan,</a:t>
+            </a:r>
+          </a:p>
+          <a:p>
+            <a:r>
+              <a:t>  97 s of AI time per scan (E3–E6). Right card: the LIDC numbers repeat the slide 6 message (E16).</a:t>
+            </a:r>
+          </a:p>
+          <a:p>
+            <a:r>
+              <a:t>- The bar chart is the honest part: manual = your estimate; 50 % = the goal; with the tool = **not measured yet**</a:t>
+            </a:r>
+          </a:p>
+          <a:p>
+            <a:r>
+              <a:t>  (E17). The app already logs every action, correction, pause and export, so one timed session produces the answer.</a:t>
+            </a:r>
+          </a:p>
+          <a:p>
+            <a:r>
+              <a:t>- Machine time is seconds (E7). The open question is your review and correction time, especially on small nodules.</a:t>
+            </a:r>
+          </a:p>
+        </p:txBody>
+      </p:sp>
+      <p:sp>
+        <p:nvSpPr>
+          <p:cNvPr id="4" name="Slide Number Placeholder 3"/>
+          <p:cNvSpPr>
+            <a:spLocks noGrp="1"/>
+          </p:cNvSpPr>
+          <p:nvPr>
+            <p:ph type="sldNum" idx="5" sz="quarter"/>
+          </p:nvPr>
+        </p:nvSpPr>
+        <p:spPr/>
+      </p:sp>
+    </p:spTree>
+  </p:cSld>
+  <p:clrMapOvr>
+    <a:masterClrMapping/>
+  </p:clrMapOvr>
+</p:notes>
+</file>
+
+<file path=ppt/notesSlides/notesSlide8.xml><?xml version="1.0" encoding="utf-8"?>
 <p:notes xmlns:a="http://schemas.openxmlformats.org/drawingml/2006/main" xmlns:p="http://schemas.openxmlformats.org/presentationml/2006/main" xmlns:r="http://schemas.openxmlformats.org/officeDocument/2006/relationships">
   <p:cSld>
     <p:spTree>
@@ -4426,6 +4543,48 @@
       <p:pic>
         <p:nvPicPr>
           <p:cNvPr id="2" name="Picture 1" descr="slide-7.png"/>
+          <p:cNvPicPr>
+            <a:picLocks noChangeAspect="1"/>
+          </p:cNvPicPr>
+          <p:nvPr/>
+        </p:nvPicPr>
+        <p:blipFill>
+          <a:blip r:embed="rId2"/>
+          <a:stretch>
+            <a:fillRect/>
+          </a:stretch>
+        </p:blipFill>
+        <p:spPr>
+          <a:xfrm>
+            <a:off x="0" y="0"/>
+            <a:ext cx="12192000" cy="6858000"/>
+          </a:xfrm>
+          <a:prstGeom prst="rect">
+            <a:avLst/>
+          </a:prstGeom>
+        </p:spPr>
+      </p:pic>
+    </p:spTree>
+  </p:cSld>
+  <p:clrMapOvr>
+    <a:masterClrMapping/>
+  </p:clrMapOvr>
+</p:sld>
+</file>
+
+<file path=ppt/slides/slide8.xml><?xml version="1.0" encoding="utf-8"?>
+<p:sld xmlns:a="http://schemas.openxmlformats.org/drawingml/2006/main" xmlns:p="http://schemas.openxmlformats.org/presentationml/2006/main" xmlns:r="http://schemas.openxmlformats.org/officeDocument/2006/relationships">
+  <p:cSld>
+    <p:spTree>
+      <p:nvGrpSpPr>
+        <p:cNvPr id="1" name=""/>
+        <p:cNvGrpSpPr/>
+        <p:nvPr/>
+      </p:nvGrpSpPr>
+      <p:grpSpPr/>
+      <p:pic>
+        <p:nvPicPr>
+          <p:cNvPr id="2" name="Picture 1" descr="slide-8.png"/>
           <p:cNvPicPr>
             <a:picLocks noChangeAspect="1"/>
           </p:cNvPicPr>

</xml_diff>

<commit_message>
Walkthrough v2: cover + objective, 9 lean slides, notes in script
Co-Authored-By: Claude Opus 5.5 <noreply@anthropic.com>

Claude-Session: https://claude.ai/code/session_01ByzH1frcmfw13KzpW7TUcX
</commit_message>
<xml_diff>
--- a/deliverables/Nodule_Research_Copilot_Daniel_Walkthrough.pptx
+++ b/deliverables/Nodule_Research_Copilot_Daniel_Walkthrough.pptx
@@ -13,6 +13,7 @@
     <p:sldId id="261" r:id="rId13"/>
     <p:sldId id="262" r:id="rId14"/>
     <p:sldId id="263" r:id="rId15"/>
+    <p:sldId id="264" r:id="rId16"/>
   </p:sldIdLst>
   <p:sldSz cx="12192000" cy="6858000" type="screen4x3"/>
   <p:notesSz cx="6858000" cy="9144000"/>
@@ -509,33 +510,28 @@
           <a:lstStyle/>
           <a:p>
             <a:r>
-              <a:t>· The research workflow problem (1.5 min)</a:t>
+              <a:t>· Nodule Research Copilot (0.5 min)</a:t>
             </a:r>
           </a:p>
           <a:p/>
           <a:p>
             <a:r>
-              <a:t>- "These are your own numbers, Daniel: 25–40 minutes per baseline scan. The two big blocks are finding nodules (two</a:t>
-            </a:r>
-          </a:p>
-          <a:p>
-            <a:r>
-              <a:t>  passes, 10–20 min) and outlining for volume (15–25 min), and that second one is why you only do it for about 1</a:t>
-            </a:r>
-          </a:p>
-          <a:p>
-            <a:r>
-              <a:t>  nodule in 5." (E1)</a:t>
-            </a:r>
-          </a:p>
-          <a:p>
-            <a:r>
-              <a:t>- "Naomi's goal is about half of that. Today that is a goal, and slide 7 shows exactly how far we have got." (E2)</a:t>
-            </a:r>
-          </a:p>
-          <a:p>
-            <a:r>
-              <a:t>- Close on the question: *can we cut this and still keep you in control of every number?*</a:t>
+              <a:t>- "I'm Yuval. This is a research tool for your lab: the AI does the first pass on a chest CT, and you stay in</a:t>
+            </a:r>
+          </a:p>
+          <a:p>
+            <a:r>
+              <a:t>  control of every number."</a:t>
+            </a:r>
+          </a:p>
+          <a:p>
+            <a:r>
+              <a:t>- Point at the image: a real public scan, with the AI outline and the expert's outline. Research prototype, not</a:t>
+            </a:r>
+          </a:p>
+          <a:p>
+            <a:r>
+              <a:t>  for clinical use.</a:t>
             </a:r>
           </a:p>
         </p:txBody>
@@ -605,53 +601,33 @@
           <a:lstStyle/>
           <a:p>
             <a:r>
-              <a:t>· From the hospital scan to your sheet (1.5 min)</a:t>
+              <a:t>· Objective (1.5 min)</a:t>
             </a:r>
           </a:p>
           <a:p/>
           <a:p>
             <a:r>
-              <a:t>- "Before the AI: this is your day with it." Walk left to right. You export the scan as for any research scan →</a:t>
-            </a:r>
-          </a:p>
-          <a:p>
-            <a:r>
-              <a:t>  one command runs the AI (overnight if you like) → open the folder in Chrome → review, fix, approve → the sheet</a:t>
-            </a:r>
-          </a:p>
-          <a:p>
-            <a:r>
-              <a:t>  fills itself.</a:t>
-            </a:r>
-          </a:p>
-          <a:p>
-            <a:r>
-              <a:t>- Only step 4 needs his judgement. Steps 2, 3 and 5 are machine time (measured: ~97 s AI per scan; ~12 s to open</a:t>
-            </a:r>
-          </a:p>
-          <a:p>
-            <a:r>
-              <a:t>  two scans with AI).</a:t>
-            </a:r>
-          </a:p>
-          <a:p>
-            <a:r>
-              <a:t>- Privacy and IT: nothing leaves the lab computer, and the browser blocks other sites (E22). There is no server and no</a:t>
-            </a:r>
-          </a:p>
-          <a:p>
-            <a:r>
-              <a:t>  PACS connection, so no IT project, which is where last year's vendor stalled.</a:t>
-            </a:r>
-          </a:p>
-          <a:p>
-            <a:r>
-              <a:t>- Be honest about the manual part: export and one command. Next: a watched folder; writing back to PACS only if</a:t>
-            </a:r>
-          </a:p>
-          <a:p>
-            <a:r>
-              <a:t>  the hospital wants it. Ask him: "How do you get research scans out of PACS today?"</a:t>
+              <a:t>- Today: 25–40 minutes per baseline scan, in Daniel's own estimate (E1). Most of it is finding nodules (10–20 min,</a:t>
+            </a:r>
+          </a:p>
+          <a:p>
+            <a:r>
+              <a:t>  two passes through 250–400 slices) and outlining for volume (15–25 min per nodule, which is why he only does it</a:t>
+            </a:r>
+          </a:p>
+          <a:p>
+            <a:r>
+              <a:t>  for about 1 in 5). The rest: ruler measurements, re-typing into the sheet, and ~10 min extra on follow-ups.</a:t>
+            </a:r>
+          </a:p>
+          <a:p>
+            <a:r>
+              <a:t>- Goal: about half (Naomi's target, E2), so 12–20 minutes.</a:t>
+            </a:r>
+          </a:p>
+          <a:p>
+            <a:r>
+              <a:t>- Three tests for success: accurate, in his control, and faster as *measured*, not promised.</a:t>
             </a:r>
           </a:p>
         </p:txBody>
@@ -721,38 +697,48 @@
           <a:lstStyle/>
           <a:p>
             <a:r>
-              <a:t>· Let AI propose the findings (2 min)</a:t>
+              <a:t>· From the hospital scan to your sheet (2 min)</a:t>
             </a:r>
           </a:p>
           <a:p/>
           <a:p>
             <a:r>
-              <a:t>- A real screenshot, a real public scan (RIDER), real model output. TotalSegmentator 2.18.0 ran on the whole CT. It</a:t>
-            </a:r>
-          </a:p>
-          <a:p>
-            <a:r>
-              <a:t>  was not told where to look, and no expert data goes into it (E20).</a:t>
-            </a:r>
-          </a:p>
-          <a:p>
-            <a:r>
-              <a:t>- It runs on the lab laptop before you sit down, about 100 seconds per scan (E6, from file timestamps). Nothing leaves</a:t>
-            </a:r>
-          </a:p>
-          <a:p>
-            <a:r>
-              <a:t>  the computer.</a:t>
-            </a:r>
-          </a:p>
-          <a:p>
-            <a:r>
-              <a:t>- Point at the worklist: N1 65.5 × 49.3 mm, 79,677 mm³, RUL; plus two tiny candidates. "Every one starts as *To</a:t>
-            </a:r>
-          </a:p>
-          <a:p>
-            <a:r>
-              <a:t>  review*. Nothing is exported until you accept it."</a:t>
+              <a:t>- Walk left to right. He exports the scan as for any research scan → one command runs the AI (~97 s per scan,</a:t>
+            </a:r>
+          </a:p>
+          <a:p>
+            <a:r>
+              <a:t>  measured; can run overnight) → he opens the folder in Chrome → he reviews, fixes and approves → the sheet fills</a:t>
+            </a:r>
+          </a:p>
+          <a:p>
+            <a:r>
+              <a:t>  itself in his columns.</a:t>
+            </a:r>
+          </a:p>
+          <a:p>
+            <a:r>
+              <a:t>- Only step 4 needs his judgement. The rest is machine time.</a:t>
+            </a:r>
+          </a:p>
+          <a:p>
+            <a:r>
+              <a:t>- Nothing leaves the lab computer, and the browser blocks connections to other sites (E22). No server and no</a:t>
+            </a:r>
+          </a:p>
+          <a:p>
+            <a:r>
+              <a:t>  hospital connection means no IT project, which is where last year's vendor stalled.</a:t>
+            </a:r>
+          </a:p>
+          <a:p>
+            <a:r>
+              <a:t>- Honest: export and the AI command are manual today. Next (not built): the AI runs by itself on new exports.</a:t>
+            </a:r>
+          </a:p>
+          <a:p>
+            <a:r>
+              <a:t>  Writing results back to the hospital system only if the hospital wants it (standard DICOM SEG).</a:t>
             </a:r>
           </a:p>
         </p:txBody>
@@ -822,43 +808,33 @@
           <a:lstStyle/>
           <a:p>
             <a:r>
-              <a:t>· Review. Correct. Approve. (2.5 min)</a:t>
+              <a:t>· The AI does the first pass (1.5 min)</a:t>
             </a:r>
           </a:p>
           <a:p/>
           <a:p>
             <a:r>
-              <a:t>- Left: the AI outline in cyan, the expert outline as dotted magenta. Right: after brush strokes on 5 slices.</a:t>
-            </a:r>
-          </a:p>
-          <a:p>
-            <a:r>
-              <a:t>- Read the table: volume 43.8 → 46.8 mL, toward the expert's 55.0. One stroke overshot the long axis (65.1 vs 59.8).</a:t>
-            </a:r>
-          </a:p>
-          <a:p>
-            <a:r>
-              <a:t>  "I'm showing that on purpose: the numbers update after every stroke, so you see a mistake right away and undo</a:t>
-            </a:r>
-          </a:p>
-          <a:p>
-            <a:r>
-              <a:t>  it with one key." (E8)</a:t>
-            </a:r>
-          </a:p>
-          <a:p>
-            <a:r>
-              <a:t>- Say plainly: *these strokes were made by our test script, not by a person*, so this shows the mechanism and says</a:t>
-            </a:r>
-          </a:p>
-          <a:p>
-            <a:r>
-              <a:t>  nothing about correction time.</a:t>
-            </a:r>
-          </a:p>
-          <a:p>
-            <a:r>
-              <a:t>- Mention **S** + click for anything the AI missed. It is logged as "added by researcher".</a:t>
+              <a:t>- A real screenshot: public RIDER scan, real output of TotalSegmentator 2.18.0, an open model. It searched the</a:t>
+            </a:r>
+          </a:p>
+          <a:p>
+            <a:r>
+              <a:t>  whole scan, and nothing told it where to look (E20).</a:t>
+            </a:r>
+          </a:p>
+          <a:p>
+            <a:r>
+              <a:t>- Each candidate is outlined in 3-D and measured: long and short axis on the largest slice, volume from the voxels,</a:t>
+            </a:r>
+          </a:p>
+          <a:p>
+            <a:r>
+              <a:t>  plus a lobe hint from the AI's lung-lobe map.</a:t>
+            </a:r>
+          </a:p>
+          <a:p>
+            <a:r>
+              <a:t>- Here: N1 65.5 × 49.3 mm (79.7 mL), plus two tiny candidates. All start as "to review".</a:t>
             </a:r>
           </a:p>
         </p:txBody>
@@ -928,33 +904,33 @@
           <a:lstStyle/>
           <a:p>
             <a:r>
-              <a:t>· Understand what changed (2 min)</a:t>
+              <a:t>· Review. Correct. Approve. (2 min)</a:t>
             </a:r>
           </a:p>
           <a:p/>
           <a:p>
             <a:r>
-              <a:t>- Baseline 2006-09-05 vs follow-up 2006-09-20, same patient. The app paired N1 with its earlier self automatically</a:t>
-            </a:r>
-          </a:p>
-          <a:p>
-            <a:r>
-              <a:t>  (38 mm apart) and computed the change: −10.1 mm long axis, −45.1 % volume. The "?" stays until you confirm (E9).</a:t>
-            </a:r>
-          </a:p>
-          <a:p>
-            <a:r>
-              <a:t>- Then the caution: the two scans were reconstructed differently (STANDARD vs LUNG kernel), the baseline has no</a:t>
-            </a:r>
-          </a:p>
-          <a:p>
-            <a:r>
-              <a:t>  expert outline, and even two scans on the same day differ by a median 10–17 % in volume (E10). "The app does the</a:t>
-            </a:r>
-          </a:p>
-          <a:p>
-            <a:r>
-              <a:t>  re-find and the arithmetic. Whether the tumour really shrank is your call."</a:t>
+              <a:t>- Left: the AI outline (cyan) and the expert's (dotted magenta). Right: after brush strokes on 5 slices.</a:t>
+            </a:r>
+          </a:p>
+          <a:p>
+            <a:r>
+              <a:t>- Volume moved 43.8 → 46.8 mL, toward the expert's 55.0 mL. One stroke overshot the long axis (65.1 vs 59.8 mm).</a:t>
+            </a:r>
+          </a:p>
+          <a:p>
+            <a:r>
+              <a:t>  "I'm showing that on purpose: every stroke re-measures, so a mistake shows at once and is one undo away." (E8)</a:t>
+            </a:r>
+          </a:p>
+          <a:p>
+            <a:r>
+              <a:t>- Say plainly: the strokes were made by our test script, so this shows the mechanism, not correction time.</a:t>
+            </a:r>
+          </a:p>
+          <a:p>
+            <a:r>
+              <a:t>- Keys: A accept, R reject, B brush, E erase, S click to add a missed nodule (logged as added by the researcher).</a:t>
             </a:r>
           </a:p>
         </p:txBody>
@@ -1024,73 +1000,33 @@
           <a:lstStyle/>
           <a:p>
             <a:r>
-              <a:t>· Small and ground-glass nodules (3 min)</a:t>
+              <a:t>· Every nodule is matched to its earlier self (1.5 min)</a:t>
             </a:r>
           </a:p>
           <a:p/>
           <a:p>
             <a:r>
-              <a:t>- "This is the slide you asked for." Start with the limitation: RIDER's smallest tumour is 12.9 mm, and there are no</a:t>
-            </a:r>
-          </a:p>
-          <a:p>
-            <a:r>
-              <a:t>  ground-glass labels.</a:t>
-            </a:r>
-          </a:p>
-          <a:p>
-            <a:r>
-              <a:t>- On tumours ≤ 30 mm: 15 of 18 found, but outlines are worse (Dice 0.68, volume 39 % off) (E12). On the 12 smallest,</a:t>
-            </a:r>
-          </a:p>
-          <a:p>
-            <a:r>
-              <a:t>  every AI outline was too small, by 26–97 % (E13).</a:t>
-            </a:r>
-          </a:p>
-          <a:p>
-            <a:r>
-              <a:t>- The failure: the same 13 mm tumour was outlined at 8 mm on one scan and **missed** on the repeat 15 minutes later</a:t>
-            </a:r>
-          </a:p>
-          <a:p>
-            <a:r>
-              <a:t>  (E14). The success: 12.9 mm found with Dice 0.81, but 15 other candidates to reject on that scan (E15).</a:t>
-            </a:r>
-          </a:p>
-          <a:p>
-            <a:r>
-              <a:t>- Then the new test you asked for (E16): LIDC-IDRI, 15 scans, 35 nodules each outlined by at least 3 radiologists,</a:t>
-            </a:r>
-          </a:p>
-          <a:p>
-            <a:r>
-              <a:t>  with the radiologists' own texture ratings. Solid: 26 of 27 found, 15 of 16 at ≤ 10 mm. **Ground-glass: 0 of 5.**</a:t>
-            </a:r>
-          </a:p>
-          <a:p>
-            <a:r>
-              <a:t>  Part-solid: 1 of 3. Show the 15.8 mm ground-glass nodule with nothing on it (E21).</a:t>
-            </a:r>
-          </a:p>
-          <a:p>
-            <a:r>
-              <a:t>- Say what it means: for hazy nodules the AI does not help today, so he keeps searching for them himself. For</a:t>
-            </a:r>
-          </a:p>
-          <a:p>
-            <a:r>
-              <a:t>  solid nodules it finds them, but every outline is too small, so he redraws before using a volume.</a:t>
-            </a:r>
-          </a:p>
-          <a:p>
-            <a:r>
-              <a:t>- If asked how we know the scoring is right: we caught a bug in our own scorer (outlines flipped on 5 scans) before</a:t>
-            </a:r>
-          </a:p>
-          <a:p>
-            <a:r>
-              <a:t>  reporting. The fix is checked by the AI's candidates landing on the radiologists' nodules.</a:t>
+              <a:t>- Baseline 5 Sep 2006 and follow-up 20 Sep 2006, same patient. The app paired N1 with its earlier self (38 mm</a:t>
+            </a:r>
+          </a:p>
+          <a:p>
+            <a:r>
+              <a:t>  apart, closest first) and computed the change. The "?" stays until he confirms (E9).</a:t>
+            </a:r>
+          </a:p>
+          <a:p>
+            <a:r>
+              <a:t>- Caution: the two scans were reconstructed differently (STANDARD vs LUNG kernel), there is no expert outline on</a:t>
+            </a:r>
+          </a:p>
+          <a:p>
+            <a:r>
+              <a:t>  the baseline, and same-day repeat scans already differ by a median of 9.5 % (our click) to 17 % (expert) in</a:t>
+            </a:r>
+          </a:p>
+          <a:p>
+            <a:r>
+              <a:t>  volume (E10). The app does the re-finding and the arithmetic; whether it shrank is his call.</a:t>
             </a:r>
           </a:p>
         </p:txBody>
@@ -1160,33 +1096,58 @@
           <a:lstStyle/>
           <a:p>
             <a:r>
-              <a:t>· Does it actually save time? (2.5 min)</a:t>
+              <a:t>· Small solid: found. Ground-glass: not yet. (2.5 min)</a:t>
             </a:r>
           </a:p>
           <a:p/>
           <a:p>
             <a:r>
-              <a:t>- Top row, measured: 53/59 found (stricter Dice ≥ 0.5: 43/59), Dice 0.76, a median of 3 extra candidates per scan,</a:t>
-            </a:r>
-          </a:p>
-          <a:p>
-            <a:r>
-              <a:t>  97 s of AI time per scan (E3–E6). Right card: the LIDC numbers repeat the slide 6 message (E16).</a:t>
-            </a:r>
-          </a:p>
-          <a:p>
-            <a:r>
-              <a:t>- The bar chart is the honest part: manual = your estimate; 50 % = the goal; with the tool = **not measured yet**</a:t>
-            </a:r>
-          </a:p>
-          <a:p>
-            <a:r>
-              <a:t>  (E17). The app already logs every action, correction, pause and export, so one timed session produces the answer.</a:t>
-            </a:r>
-          </a:p>
-          <a:p>
-            <a:r>
-              <a:t>- Machine time is seconds (E7). The open question is your review and correction time, especially on small nodules.</a:t>
+              <a:t>- "This is the slide you asked for." LIDC-IDRI: 15 public scans selected by fixed rules, 35 nodules each outlined by</a:t>
+            </a:r>
+          </a:p>
+          <a:p>
+            <a:r>
+              <a:t>  at least 3 of 4 radiologists, with their own texture ratings (E16).</a:t>
+            </a:r>
+          </a:p>
+          <a:p>
+            <a:r>
+              <a:t>- Solid: 26 of 27 found, 15 of 16 at ≤ 10 mm. But every outline the AI produced was too small (−26 % to −91 % in</a:t>
+            </a:r>
+          </a:p>
+          <a:p>
+            <a:r>
+              <a:t>  volume), so he redraws before using a volume.</a:t>
+            </a:r>
+          </a:p>
+          <a:p>
+            <a:r>
+              <a:t>- Part-solid 1 of 3. **Ground-glass 0 of 5.** Show the 15.8 mm ground-glass nodule with nothing on it (E21). For hazy</a:t>
+            </a:r>
+          </a:p>
+          <a:p>
+            <a:r>
+              <a:t>  nodules the AI does not help today; he keeps searching for them himself.</a:t>
+            </a:r>
+          </a:p>
+          <a:p>
+            <a:r>
+              <a:t>- Images 2 and 3 are from RIDER: a 13.5 mm tumour outlined at 8.0 mm (and missed entirely on a repeat scan 15</a:t>
+            </a:r>
+          </a:p>
+          <a:p>
+            <a:r>
+              <a:t>  minutes later, E14), and a 12.9 mm tumour matched closely (Dice 0.81, E15).</a:t>
+            </a:r>
+          </a:p>
+          <a:p>
+            <a:r>
+              <a:t>- If asked how we know the scoring is right: we caught a bug in our own scorer (outlines flipped on 5 scans) before</a:t>
+            </a:r>
+          </a:p>
+          <a:p>
+            <a:r>
+              <a:t>  reporting, and the AI's candidates landing on the radiologists' nodules confirmed the fix.</a:t>
             </a:r>
           </a:p>
         </p:txBody>
@@ -1256,33 +1217,134 @@
           <a:lstStyle/>
           <a:p>
             <a:r>
-              <a:t>· What would make this trustworthy? (1.5 min + discussion)</a:t>
+              <a:t>· What is proven, and what is not yet (2 min)</a:t>
             </a:r>
           </a:p>
           <a:p/>
           <a:p>
             <a:r>
-              <a:t>- Read Daniel's quote (E18). Say it is his written feedback, not an observation of him using the tool.</a:t>
-            </a:r>
-          </a:p>
-          <a:p>
-            <a:r>
-              <a:t>- Status on his three points: review and correction built; timing instrumented but not run; small solid tested with</a:t>
-            </a:r>
-          </a:p>
-          <a:p>
-            <a:r>
-              <a:t>  failures shown, ground-glass pending.</a:t>
-            </a:r>
-          </a:p>
-          <a:p>
-            <a:r>
-              <a:t>- Ask the four questions and write the answers down word for word. Propose the next step: a 15–20 minute timed</a:t>
-            </a:r>
-          </a:p>
-          <a:p>
-            <a:r>
-              <a:t>  session (RESEARCHER_TEST_PROTOCOL.md) on public scans, manual vs AI-assisted.</a:t>
+              <a:t>- Measured: 53 of 59 known tumours found on RIDER (90 %; stricter Dice ≥ 0.5: 43/59), median overlap with the expert</a:t>
+            </a:r>
+          </a:p>
+          <a:p>
+            <a:r>
+              <a:t>  outline 0.76, AI time 97 s per scan (E3–E6). Context, not equivalence: on one scan, 5 readers using a</a:t>
+            </a:r>
+          </a:p>
+          <a:p>
+            <a:r>
+              <a:t>  semi-automatic tool scored 0.77–0.90 against the same expert (E19).</a:t>
+            </a:r>
+          </a:p>
+          <a:p>
+            <a:r>
+              <a:t>- Time: today 25–40 min (his estimate), goal 12–20 min, with the tool **not measured yet** (E17). The app already</a:t>
+            </a:r>
+          </a:p>
+          <a:p>
+            <a:r>
+              <a:t>  logs every action, correction and pause, so one timed session gives the answer.</a:t>
+            </a:r>
+          </a:p>
+          <a:p>
+            <a:r>
+              <a:t>- Not proven: researcher time saved, and ground-glass. False positives are only an upper bound (LIDC: a median of 1</a:t>
+            </a:r>
+          </a:p>
+          <a:p>
+            <a:r>
+              <a:t>  extra candidate per scan).</a:t>
+            </a:r>
+          </a:p>
+        </p:txBody>
+      </p:sp>
+      <p:sp>
+        <p:nvSpPr>
+          <p:cNvPr id="4" name="Slide Number Placeholder 3"/>
+          <p:cNvSpPr>
+            <a:spLocks noGrp="1"/>
+          </p:cNvSpPr>
+          <p:nvPr>
+            <p:ph type="sldNum" idx="5" sz="quarter"/>
+          </p:nvPr>
+        </p:nvSpPr>
+        <p:spPr/>
+      </p:sp>
+    </p:spTree>
+  </p:cSld>
+  <p:clrMapOvr>
+    <a:masterClrMapping/>
+  </p:clrMapOvr>
+</p:notes>
+</file>
+
+<file path=ppt/notesSlides/notesSlide9.xml><?xml version="1.0" encoding="utf-8"?>
+<p:notes xmlns:a="http://schemas.openxmlformats.org/drawingml/2006/main" xmlns:p="http://schemas.openxmlformats.org/presentationml/2006/main" xmlns:r="http://schemas.openxmlformats.org/officeDocument/2006/relationships">
+  <p:cSld>
+    <p:spTree>
+      <p:nvGrpSpPr>
+        <p:cNvPr id="1" name=""/>
+        <p:cNvGrpSpPr/>
+        <p:nvPr/>
+      </p:nvGrpSpPr>
+      <p:grpSpPr>
+        <a:xfrm>
+          <a:off x="0" y="0"/>
+          <a:ext cx="0" cy="0"/>
+          <a:chOff x="0" y="0"/>
+          <a:chExt cx="0" cy="0"/>
+        </a:xfrm>
+      </p:grpSpPr>
+      <p:sp>
+        <p:nvSpPr>
+          <p:cNvPr id="2" name="Slide Image Placeholder 1"/>
+          <p:cNvSpPr>
+            <a:spLocks noGrp="1"/>
+          </p:cNvSpPr>
+          <p:nvPr>
+            <p:ph type="sldImg" idx="2"/>
+          </p:nvPr>
+        </p:nvSpPr>
+        <p:spPr/>
+      </p:sp>
+      <p:sp>
+        <p:nvSpPr>
+          <p:cNvPr id="3" name="Notes Placeholder 2"/>
+          <p:cNvSpPr>
+            <a:spLocks noGrp="1"/>
+          </p:cNvSpPr>
+          <p:nvPr>
+            <p:ph type="body" idx="3" sz="quarter"/>
+          </p:nvPr>
+        </p:nvSpPr>
+        <p:spPr/>
+        <p:txBody>
+          <a:bodyPr/>
+          <a:lstStyle/>
+          <a:p>
+            <a:r>
+              <a:t>· What would make this worth using? (1 min + discussion)</a:t>
+            </a:r>
+          </a:p>
+          <a:p/>
+          <a:p>
+            <a:r>
+              <a:t>- Read his quote. It is his written feedback, not an observation of him using the tool (E18).</a:t>
+            </a:r>
+          </a:p>
+          <a:p>
+            <a:r>
+              <a:t>- Ask the three questions and write the answers down word for word.</a:t>
+            </a:r>
+          </a:p>
+          <a:p>
+            <a:r>
+              <a:t>- Propose the next step: a 20-minute timed session on 10 public scans, manual vs with the tool</a:t>
+            </a:r>
+          </a:p>
+          <a:p>
+            <a:r>
+              <a:t>  (`docs/RESEARCHER_TEST_PROTOCOL.md`).</a:t>
             </a:r>
           </a:p>
         </p:txBody>
@@ -4585,6 +4647,48 @@
       <p:pic>
         <p:nvPicPr>
           <p:cNvPr id="2" name="Picture 1" descr="slide-8.png"/>
+          <p:cNvPicPr>
+            <a:picLocks noChangeAspect="1"/>
+          </p:cNvPicPr>
+          <p:nvPr/>
+        </p:nvPicPr>
+        <p:blipFill>
+          <a:blip r:embed="rId2"/>
+          <a:stretch>
+            <a:fillRect/>
+          </a:stretch>
+        </p:blipFill>
+        <p:spPr>
+          <a:xfrm>
+            <a:off x="0" y="0"/>
+            <a:ext cx="12192000" cy="6858000"/>
+          </a:xfrm>
+          <a:prstGeom prst="rect">
+            <a:avLst/>
+          </a:prstGeom>
+        </p:spPr>
+      </p:pic>
+    </p:spTree>
+  </p:cSld>
+  <p:clrMapOvr>
+    <a:masterClrMapping/>
+  </p:clrMapOvr>
+</p:sld>
+</file>
+
+<file path=ppt/slides/slide9.xml><?xml version="1.0" encoding="utf-8"?>
+<p:sld xmlns:a="http://schemas.openxmlformats.org/drawingml/2006/main" xmlns:p="http://schemas.openxmlformats.org/presentationml/2006/main" xmlns:r="http://schemas.openxmlformats.org/officeDocument/2006/relationships">
+  <p:cSld>
+    <p:spTree>
+      <p:nvGrpSpPr>
+        <p:cNvPr id="1" name=""/>
+        <p:cNvGrpSpPr/>
+        <p:nvPr/>
+      </p:nvGrpSpPr>
+      <p:grpSpPr/>
+      <p:pic>
+        <p:nvPicPr>
+          <p:cNvPr id="2" name="Picture 1" descr="slide-9.png"/>
           <p:cNvPicPr>
             <a:picLocks noChangeAspect="1"/>
           </p:cNvPicPr>

</xml_diff>

<commit_message>
Walkthrough v2 after review: accurate privacy/setup claims, successful correction example, realistic next step; run-ai turns off TotalSegmentator usage stats
Co-Authored-By: Claude Opus 5.5 <noreply@anthropic.com>

Claude-Session: https://claude.ai/code/session_01ByzH1frcmfw13KzpW7TUcX
</commit_message>
<xml_diff>
--- a/deliverables/Nodule_Research_Copilot_Daniel_Walkthrough.pptx
+++ b/deliverables/Nodule_Research_Copilot_Daniel_Walkthrough.pptx
@@ -708,12 +708,12 @@
           </a:p>
           <a:p>
             <a:r>
-              <a:t>  measured; can run overnight) → he opens the folder in Chrome → he reviews, fixes and approves → the sheet fills</a:t>
-            </a:r>
-          </a:p>
-          <a:p>
-            <a:r>
-              <a:t>  itself in his columns.</a:t>
+              <a:t>  measured; can run overnight) → he opens the folder in Chrome → he reviews, fixes and approves → approved nodules</a:t>
+            </a:r>
+          </a:p>
+          <a:p>
+            <a:r>
+              <a:t>  export as a CSV in his sheet's columns (opens in Excel).</a:t>
             </a:r>
           </a:p>
           <a:p>
@@ -723,12 +723,22 @@
           </a:p>
           <a:p>
             <a:r>
-              <a:t>- Nothing leaves the lab computer, and the browser blocks connections to other sites (E22). No server and no</a:t>
-            </a:r>
-          </a:p>
-          <a:p>
-            <a:r>
-              <a:t>  hospital connection means no IT project, which is where last year's vendor stalled.</a:t>
+              <a:t>- Scans stay on the lab computer: the browser blocks connections to other sites (verified, E22). The AI model</a:t>
+            </a:r>
+          </a:p>
+          <a:p>
+            <a:r>
+              <a:t>  sends anonymous usage statistics by default; our run script switches that off before every run.</a:t>
+            </a:r>
+          </a:p>
+          <a:p>
+            <a:r>
+              <a:t>- Setup is one Python install (TotalSegmentator) on the lab computer. No server and no hospital connection, so no</a:t>
+            </a:r>
+          </a:p>
+          <a:p>
+            <a:r>
+              <a:t>  integration project. Whether installing Python on a hospital laptop needs IT sign-off is their policy; ask.</a:t>
             </a:r>
           </a:p>
           <a:p>
@@ -915,17 +925,27 @@
           </a:p>
           <a:p>
             <a:r>
-              <a:t>- Volume moved 43.8 → 46.8 mL, toward the expert's 55.0 mL. One stroke overshot the long axis (65.1 vs 59.8 mm).</a:t>
-            </a:r>
-          </a:p>
-          <a:p>
-            <a:r>
-              <a:t>  "I'm showing that on purpose: every stroke re-measures, so a mistake shows at once and is one undo away." (E8)</a:t>
-            </a:r>
-          </a:p>
-          <a:p>
-            <a:r>
-              <a:t>- Say plainly: the strokes were made by our test script, so this shows the mechanism, not correction time.</a:t>
+              <a:t>- All three numbers moved toward the expert: volume 43.8 → 46.5 mL (expert 55.0), long axis 55.4 → 62.8 mm</a:t>
+            </a:r>
+          </a:p>
+          <a:p>
+            <a:r>
+              <a:t>  (expert 59.8, error 4.4 → 3.0 mm), Dice 0.87 → 0.88 (E8). Every stroke re-measures, so a wrong stroke shows at</a:t>
+            </a:r>
+          </a:p>
+          <a:p>
+            <a:r>
+              <a:t>  once and is one undo away.</a:t>
+            </a:r>
+          </a:p>
+          <a:p>
+            <a:r>
+              <a:t>- Say plainly: the strokes were made by our test script, so this shows the mechanism, not how long it takes a</a:t>
+            </a:r>
+          </a:p>
+          <a:p>
+            <a:r>
+              <a:t>  person. Correction time is the open question (slide 8).</a:t>
             </a:r>
           </a:p>
           <a:p>
@@ -1000,7 +1020,7 @@
           <a:lstStyle/>
           <a:p>
             <a:r>
-              <a:t>· Every nodule is matched to its earlier self (1.5 min)</a:t>
+              <a:t>· Each nodule gets a suggested match from the earlier scan (1.5 min)</a:t>
             </a:r>
           </a:p>
           <a:p/>
@@ -1223,12 +1243,17 @@
           <a:p/>
           <a:p>
             <a:r>
-              <a:t>- Measured: 53 of 59 known tumours found on RIDER (90 %; stricter Dice ≥ 0.5: 43/59), median overlap with the expert</a:t>
-            </a:r>
-          </a:p>
-          <a:p>
-            <a:r>
-              <a:t>  outline 0.76, AI time 97 s per scan (E3–E6). Context, not equivalence: on one scan, 5 readers using a</a:t>
+              <a:t>- Measured on RIDER: 59 scans of 31 patients (TEST + RETEST), one expert-labelled tumour per scan. The tumour was</a:t>
+            </a:r>
+          </a:p>
+          <a:p>
+            <a:r>
+              <a:t>  found on 53 (90 %; stricter Dice ≥ 0.5: 43/59). Median Dice 0.76 over the 53 found (misses excluded, listed</a:t>
+            </a:r>
+          </a:p>
+          <a:p>
+            <a:r>
+              <a:t>  separately). A median of 3 extra candidates per scan to reject, up to 30 on a few scans. AI time 97 s (E3–E6). Context, not equivalence: on one scan, 5 readers using a</a:t>
             </a:r>
           </a:p>
           <a:p>
@@ -1248,12 +1273,17 @@
           </a:p>
           <a:p>
             <a:r>
-              <a:t>- Not proven: researcher time saved, and ground-glass. False positives are only an upper bound (LIDC: a median of 1</a:t>
-            </a:r>
-          </a:p>
-          <a:p>
-            <a:r>
-              <a:t>  extra candidate per scan).</a:t>
+              <a:t>- Not proven: researcher time saved, and ground-glass. Time saved will depend mostly on how long the edge</a:t>
+            </a:r>
+          </a:p>
+          <a:p>
+            <a:r>
+              <a:t>  corrections take, since every solid outline came out too small. False positives are only an upper bound (LIDC:</a:t>
+            </a:r>
+          </a:p>
+          <a:p>
+            <a:r>
+              <a:t>  a median of 1 extra candidate per scan).</a:t>
             </a:r>
           </a:p>
         </p:txBody>
@@ -1334,17 +1364,27 @@
           </a:p>
           <a:p>
             <a:r>
-              <a:t>- Ask the three questions and write the answers down word for word.</a:t>
-            </a:r>
-          </a:p>
-          <a:p>
-            <a:r>
-              <a:t>- Propose the next step: a 20-minute timed session on 10 public scans, manual vs with the tool</a:t>
-            </a:r>
-          </a:p>
-          <a:p>
-            <a:r>
-              <a:t>  (`docs/RESEARCHER_TEST_PROTOCOL.md`).</a:t>
+              <a:t>- Ask the three questions and write the answers down word for word. Question 1 is a task, not an opinion: he already</a:t>
+            </a:r>
+          </a:p>
+          <a:p>
+            <a:r>
+              <a:t>  said the flow fits; now we want to see where he gets stuck.</a:t>
+            </a:r>
+          </a:p>
+          <a:p>
+            <a:r>
+              <a:t>- Next step: a 20-minute hands-on session on one scan (`docs/RESEARCHER_TEST_PROTOCOL.md`). Then a planned timing</a:t>
+            </a:r>
+          </a:p>
+          <a:p>
+            <a:r>
+              <a:t>  study: the same task on a few scans, manual vs with the tool, with correction time measured separately and the</a:t>
+            </a:r>
+          </a:p>
+          <a:p>
+            <a:r>
+              <a:t>  order swapped to limit learning effects (`docs/TIME_SAVINGS_EVALUATION.md` §5).</a:t>
             </a:r>
           </a:p>
         </p:txBody>

</xml_diff>

<commit_message>
Hide expert reference panel during timed tasks; walkthrough deck updated (suggested-only matching, re-approval, candidates to review, timed tasks)
Co-Authored-By: Claude Opus 5.5 <noreply@anthropic.com>
Claude-Session: https://claude.ai/code/session_01ByzH1frcMFw13KzpW7TUcX
</commit_message>
<xml_diff>
--- a/deliverables/Nodule_Research_Copilot_Daniel_Walkthrough.pptx
+++ b/deliverables/Nodule_Research_Copilot_Daniel_Walkthrough.pptx
@@ -708,17 +708,17 @@
           </a:p>
           <a:p>
             <a:r>
-              <a:t>  measured; can run overnight) → he opens the folder in Chrome → he reviews, fixes and approves → approved nodules</a:t>
-            </a:r>
-          </a:p>
-          <a:p>
-            <a:r>
-              <a:t>  export as a CSV in his sheet's columns (opens in Excel).</a:t>
-            </a:r>
-          </a:p>
-          <a:p>
-            <a:r>
-              <a:t>- Only step 4 needs his judgement. The rest is machine time.</a:t>
+              <a:t>  measured; can run overnight) → he opens the folder in Chrome → he reviews, fixes and approves → one click exports</a:t>
+            </a:r>
+          </a:p>
+          <a:p>
+            <a:r>
+              <a:t>  the approved nodules as a CSV in his sheet's columns (opens in Excel).</a:t>
+            </a:r>
+          </a:p>
+          <a:p>
+            <a:r>
+              <a:t>- Only step 4 needs his judgement; step 5 is one click. The rest is machine time.</a:t>
             </a:r>
           </a:p>
           <a:p>
@@ -950,7 +950,22 @@
           </a:p>
           <a:p>
             <a:r>
-              <a:t>- Keys: A accept, R reject, B brush, E erase, S click to add a missed nodule (logged as added by the researcher).</a:t>
+              <a:t>- Keys: A accept, R reject, B brush, E erase, S click to add a missed nodule (logged as added by the researcher), ⌘Z undo.</a:t>
+            </a:r>
+          </a:p>
+          <a:p>
+            <a:r>
+              <a:t>- If he edits a nodule he already approved, it goes back to "Re-approve" and is left out of the export until he accepts</a:t>
+            </a:r>
+          </a:p>
+          <a:p>
+            <a:r>
+              <a:t>  it again. The AI's original numbers stay in the export next to his.</a:t>
+            </a:r>
+          </a:p>
+          <a:p>
+            <a:r>
+              <a:t>- A nodule outlined on one slice only gets diameters, no volume; the app says so.</a:t>
             </a:r>
           </a:p>
         </p:txBody>
@@ -1031,7 +1046,12 @@
           </a:p>
           <a:p>
             <a:r>
-              <a:t>  apart, closest first) and computed the change. The "?" stays until he confirms (E9).</a:t>
+              <a:t>  apart, closest first) and computed the change. The "?" stays until he confirms:</a:t>
+            </a:r>
+          </a:p>
+          <a:p>
+            <a:r>
+              <a:t>  accepting the measurement (A) does not confirm the match. M confirms it; "Not in earlier scan" records no match (E9).</a:t>
             </a:r>
           </a:p>
           <a:p>
@@ -1253,7 +1273,7 @@
           </a:p>
           <a:p>
             <a:r>
-              <a:t>  separately). A median of 3 extra candidates per scan to reject, up to 30 on a few scans. AI time 97 s (E3–E6). Context, not equivalence: on one scan, 5 readers using a</a:t>
+              <a:t>  separately). A median of 3 additional candidates per scan to review, up to 30 on a few scans (not adjudicated, so not called false positives). AI time 97 s (E3–E6). Context, not equivalence: on one scan, 5 readers using a</a:t>
             </a:r>
           </a:p>
           <a:p>
@@ -1263,12 +1283,17 @@
           </a:p>
           <a:p>
             <a:r>
-              <a:t>- Time: today 25–40 min (his estimate), goal 12–20 min, with the tool **not measured yet** (E17). The app already</a:t>
-            </a:r>
-          </a:p>
-          <a:p>
-            <a:r>
-              <a:t>  logs every action, correction and pause, so one timed session gives the answer.</a:t>
+              <a:t>- Time: today 25–40 min (his estimate), goal 12–20 min, with the tool **not measured yet** (E17). The app now</a:t>
+            </a:r>
+          </a:p>
+          <a:p>
+            <a:r>
+              <a:t>  times a task explicitly (Start → Finish, pauses excluded, expert outline hidden) and splits review, correction and</a:t>
+            </a:r>
+          </a:p>
+          <a:p>
+            <a:r>
+              <a:t>  export time. Time saved needs manual sessions on the same scans as well, timed by an observer.</a:t>
             </a:r>
           </a:p>
           <a:p>
@@ -1374,7 +1399,12 @@
           </a:p>
           <a:p>
             <a:r>
-              <a:t>- Next step: a 20-minute hands-on session on one scan (`docs/RESEARCHER_TEST_PROTOCOL.md`). Then a planned timing</a:t>
+              <a:t>- Next step: a 20-minute hands-on session on one scan (`docs/PILOT_READINESS.md` §6a). It is about where he gets stuck;</a:t>
+            </a:r>
+          </a:p>
+          <a:p>
+            <a:r>
+              <a:t>  its times are not used for time saved. Then a planned timing</a:t>
             </a:r>
           </a:p>
           <a:p>
@@ -1384,7 +1414,43 @@
           </a:p>
           <a:p>
             <a:r>
-              <a:t>  order swapped to limit learning effects (`docs/TIME_SAVINGS_EVALUATION.md` §5).</a:t>
+              <a:t>  order swapped to limit learning effects (`docs/PILOT_READINESS.md` §6b).</a:t>
+            </a:r>
+          </a:p>
+          <a:p/>
+          <a:p>
+            <a:r>
+              <a:t>If asked:</a:t>
+            </a:r>
+          </a:p>
+          <a:p>
+            <a:r>
+              <a:t>- *"Is it as good as a radiologist?"* We don't claim that. See slide 8 context: one scan, semi-automatic readers.</a:t>
+            </a:r>
+          </a:p>
+          <a:p>
+            <a:r>
+              <a:t>- *"False positives?"* Not measurable on RIDER (one tumour labelled per scan). LIDC gives an upper bound: median 1</a:t>
+            </a:r>
+          </a:p>
+          <a:p>
+            <a:r>
+              <a:t>  extra candidate per scan.</a:t>
+            </a:r>
+          </a:p>
+          <a:p>
+            <a:r>
+              <a:t>- *"Does data leave the computer?"* No. The browser blocks other sites (CSP), and the AI runs locally.</a:t>
+            </a:r>
+          </a:p>
+          <a:p>
+            <a:r>
+              <a:t>- *"Why not write results back to PACS?"* It's a research tool, and his output today is a research sheet. Writing</a:t>
+            </a:r>
+          </a:p>
+          <a:p>
+            <a:r>
+              <a:t>  back is possible (DICOM SEG) but needs the hospital's IT, so it's a phase-2 choice for them.</a:t>
             </a:r>
           </a:p>
         </p:txBody>

</xml_diff>

<commit_message>
Final pass: LIDC training-overlap caveat, stricter 43/59 shown, real screenshot names, incomplete-export guard, auto-filled Type/Lobe provenance, storage-failure warning, timing estimates labelled, privacy wording
Co-Authored-By: Claude Opus 5.5 <noreply@anthropic.com>
Claude-Session: https://claude.ai/code/session_01ByzH1frcMFw13KzpW7TUcX
</commit_message>
<xml_diff>
--- a/deliverables/Nodule_Research_Copilot_Daniel_Walkthrough.pptx
+++ b/deliverables/Nodule_Research_Copilot_Daniel_Walkthrough.pptx
@@ -1157,7 +1157,12 @@
           </a:p>
           <a:p>
             <a:r>
-              <a:t>  volume), so he redraws before using a volume.</a:t>
+              <a:t>  volume), so he redraws before using a volume. Caveat if asked: the model was trained partly on LIDC-IDRI, so these</a:t>
+            </a:r>
+          </a:p>
+          <a:p>
+            <a:r>
+              <a:t>  detection rates may be optimistic; an independent test set is needed for a fair rate.</a:t>
             </a:r>
           </a:p>
           <a:p>

</xml_diff>